<commit_message>
Tutorial and a reform of the entire game
</commit_message>
<xml_diff>
--- a/images/drawingTheTutorial.pptx
+++ b/images/drawingTheTutorial.pptx
@@ -8,6 +8,8 @@
     <p:sldId id="256" r:id="rId2"/>
     <p:sldId id="257" r:id="rId3"/>
     <p:sldId id="259" r:id="rId4"/>
+    <p:sldId id="260" r:id="rId5"/>
+    <p:sldId id="261" r:id="rId6"/>
   </p:sldIdLst>
   <p:sldSz cx="12192000" cy="6858000"/>
   <p:notesSz cx="6858000" cy="9144000"/>
@@ -4111,6 +4113,59 @@
           </a:prstGeom>
         </p:spPr>
       </p:pic>
+      <p:pic>
+        <p:nvPicPr>
+          <p:cNvPr id="6" name="Image 5">
+            <a:extLst>
+              <a:ext uri="{FF2B5EF4-FFF2-40B4-BE49-F238E27FC236}">
+                <a16:creationId xmlns:a16="http://schemas.microsoft.com/office/drawing/2014/main" id="{7FEF68F1-1380-1CD3-D898-287099ADDA80}"/>
+              </a:ext>
+            </a:extLst>
+          </p:cNvPr>
+          <p:cNvPicPr>
+            <a:picLocks noChangeAspect="1"/>
+          </p:cNvPicPr>
+          <p:nvPr/>
+        </p:nvPicPr>
+        <p:blipFill>
+          <a:blip r:embed="rId18">
+            <a:duotone>
+              <a:schemeClr val="bg2">
+                <a:shade val="45000"/>
+                <a:satMod val="135000"/>
+              </a:schemeClr>
+              <a:prstClr val="white"/>
+            </a:duotone>
+            <a:extLst>
+              <a:ext uri="{BEBA8EAE-BF5A-486C-A8C5-ECC9F3942E4B}">
+                <a14:imgProps xmlns:a14="http://schemas.microsoft.com/office/drawing/2010/main">
+                  <a14:imgLayer r:embed="rId19">
+                    <a14:imgEffect>
+                      <a14:colorTemperature colorTemp="4700"/>
+                    </a14:imgEffect>
+                    <a14:imgEffect>
+                      <a14:saturation sat="0"/>
+                    </a14:imgEffect>
+                  </a14:imgLayer>
+                </a14:imgProps>
+              </a:ext>
+            </a:extLst>
+          </a:blip>
+          <a:srcRect l="1287" t="17358" r="73201" b="14299"/>
+          <a:stretch>
+            <a:fillRect/>
+          </a:stretch>
+        </p:blipFill>
+        <p:spPr>
+          <a:xfrm rot="10800000">
+            <a:off x="11433373" y="6098266"/>
+            <a:ext cx="758627" cy="759734"/>
+          </a:xfrm>
+          <a:prstGeom prst="rect">
+            <a:avLst/>
+          </a:prstGeom>
+        </p:spPr>
+      </p:pic>
     </p:spTree>
     <p:extLst>
       <p:ext uri="{BB962C8B-B14F-4D97-AF65-F5344CB8AC3E}">
@@ -4421,6 +4476,112 @@
           <a:xfrm>
             <a:off x="3864077" y="0"/>
             <a:ext cx="4463845" cy="1053879"/>
+          </a:xfrm>
+          <a:prstGeom prst="rect">
+            <a:avLst/>
+          </a:prstGeom>
+        </p:spPr>
+      </p:pic>
+      <p:pic>
+        <p:nvPicPr>
+          <p:cNvPr id="4" name="Image 3">
+            <a:extLst>
+              <a:ext uri="{FF2B5EF4-FFF2-40B4-BE49-F238E27FC236}">
+                <a16:creationId xmlns:a16="http://schemas.microsoft.com/office/drawing/2014/main" id="{5CA3B1E5-CFC5-A431-47B9-586221BF6312}"/>
+              </a:ext>
+            </a:extLst>
+          </p:cNvPr>
+          <p:cNvPicPr>
+            <a:picLocks noChangeAspect="1"/>
+          </p:cNvPicPr>
+          <p:nvPr/>
+        </p:nvPicPr>
+        <p:blipFill>
+          <a:blip r:embed="rId8">
+            <a:duotone>
+              <a:schemeClr val="bg2">
+                <a:shade val="45000"/>
+                <a:satMod val="135000"/>
+              </a:schemeClr>
+              <a:prstClr val="white"/>
+            </a:duotone>
+            <a:extLst>
+              <a:ext uri="{BEBA8EAE-BF5A-486C-A8C5-ECC9F3942E4B}">
+                <a14:imgProps xmlns:a14="http://schemas.microsoft.com/office/drawing/2010/main">
+                  <a14:imgLayer r:embed="rId9">
+                    <a14:imgEffect>
+                      <a14:colorTemperature colorTemp="4700"/>
+                    </a14:imgEffect>
+                    <a14:imgEffect>
+                      <a14:saturation sat="0"/>
+                    </a14:imgEffect>
+                  </a14:imgLayer>
+                </a14:imgProps>
+              </a:ext>
+            </a:extLst>
+          </a:blip>
+          <a:srcRect l="1287" t="17358" r="73201" b="14299"/>
+          <a:stretch>
+            <a:fillRect/>
+          </a:stretch>
+        </p:blipFill>
+        <p:spPr>
+          <a:xfrm>
+            <a:off x="0" y="6098266"/>
+            <a:ext cx="758627" cy="759734"/>
+          </a:xfrm>
+          <a:prstGeom prst="rect">
+            <a:avLst/>
+          </a:prstGeom>
+        </p:spPr>
+      </p:pic>
+      <p:pic>
+        <p:nvPicPr>
+          <p:cNvPr id="5" name="Image 4">
+            <a:extLst>
+              <a:ext uri="{FF2B5EF4-FFF2-40B4-BE49-F238E27FC236}">
+                <a16:creationId xmlns:a16="http://schemas.microsoft.com/office/drawing/2014/main" id="{AC8A5FB9-EB99-410D-2652-F83543530159}"/>
+              </a:ext>
+            </a:extLst>
+          </p:cNvPr>
+          <p:cNvPicPr>
+            <a:picLocks noChangeAspect="1"/>
+          </p:cNvPicPr>
+          <p:nvPr/>
+        </p:nvPicPr>
+        <p:blipFill>
+          <a:blip r:embed="rId8">
+            <a:duotone>
+              <a:schemeClr val="bg2">
+                <a:shade val="45000"/>
+                <a:satMod val="135000"/>
+              </a:schemeClr>
+              <a:prstClr val="white"/>
+            </a:duotone>
+            <a:extLst>
+              <a:ext uri="{BEBA8EAE-BF5A-486C-A8C5-ECC9F3942E4B}">
+                <a14:imgProps xmlns:a14="http://schemas.microsoft.com/office/drawing/2010/main">
+                  <a14:imgLayer r:embed="rId9">
+                    <a14:imgEffect>
+                      <a14:colorTemperature colorTemp="4700"/>
+                    </a14:imgEffect>
+                    <a14:imgEffect>
+                      <a14:saturation sat="0"/>
+                    </a14:imgEffect>
+                  </a14:imgLayer>
+                </a14:imgProps>
+              </a:ext>
+            </a:extLst>
+          </a:blip>
+          <a:srcRect l="1287" t="17358" r="73201" b="14299"/>
+          <a:stretch>
+            <a:fillRect/>
+          </a:stretch>
+        </p:blipFill>
+        <p:spPr>
+          <a:xfrm rot="10800000">
+            <a:off x="11433373" y="6098266"/>
+            <a:ext cx="758627" cy="759734"/>
           </a:xfrm>
           <a:prstGeom prst="rect">
             <a:avLst/>
@@ -4824,10 +4985,835 @@
           </a:prstGeom>
         </p:spPr>
       </p:pic>
+      <p:pic>
+        <p:nvPicPr>
+          <p:cNvPr id="4" name="Image 3">
+            <a:extLst>
+              <a:ext uri="{FF2B5EF4-FFF2-40B4-BE49-F238E27FC236}">
+                <a16:creationId xmlns:a16="http://schemas.microsoft.com/office/drawing/2014/main" id="{833F7461-9F21-8020-1E1B-DC70A85E84BE}"/>
+              </a:ext>
+            </a:extLst>
+          </p:cNvPr>
+          <p:cNvPicPr>
+            <a:picLocks noChangeAspect="1"/>
+          </p:cNvPicPr>
+          <p:nvPr/>
+        </p:nvPicPr>
+        <p:blipFill>
+          <a:blip r:embed="rId8">
+            <a:duotone>
+              <a:schemeClr val="bg2">
+                <a:shade val="45000"/>
+                <a:satMod val="135000"/>
+              </a:schemeClr>
+              <a:prstClr val="white"/>
+            </a:duotone>
+            <a:extLst>
+              <a:ext uri="{BEBA8EAE-BF5A-486C-A8C5-ECC9F3942E4B}">
+                <a14:imgProps xmlns:a14="http://schemas.microsoft.com/office/drawing/2010/main">
+                  <a14:imgLayer r:embed="rId9">
+                    <a14:imgEffect>
+                      <a14:colorTemperature colorTemp="4700"/>
+                    </a14:imgEffect>
+                    <a14:imgEffect>
+                      <a14:saturation sat="0"/>
+                    </a14:imgEffect>
+                  </a14:imgLayer>
+                </a14:imgProps>
+              </a:ext>
+            </a:extLst>
+          </a:blip>
+          <a:srcRect l="1287" t="17358" r="73201" b="14299"/>
+          <a:stretch>
+            <a:fillRect/>
+          </a:stretch>
+        </p:blipFill>
+        <p:spPr>
+          <a:xfrm>
+            <a:off x="0" y="6098266"/>
+            <a:ext cx="758627" cy="759734"/>
+          </a:xfrm>
+          <a:prstGeom prst="rect">
+            <a:avLst/>
+          </a:prstGeom>
+        </p:spPr>
+      </p:pic>
+      <p:pic>
+        <p:nvPicPr>
+          <p:cNvPr id="5" name="Image 4">
+            <a:extLst>
+              <a:ext uri="{FF2B5EF4-FFF2-40B4-BE49-F238E27FC236}">
+                <a16:creationId xmlns:a16="http://schemas.microsoft.com/office/drawing/2014/main" id="{CEF182DA-2B88-0611-C71F-FBEE6473C296}"/>
+              </a:ext>
+            </a:extLst>
+          </p:cNvPr>
+          <p:cNvPicPr>
+            <a:picLocks noChangeAspect="1"/>
+          </p:cNvPicPr>
+          <p:nvPr/>
+        </p:nvPicPr>
+        <p:blipFill>
+          <a:blip r:embed="rId8">
+            <a:duotone>
+              <a:schemeClr val="bg2">
+                <a:shade val="45000"/>
+                <a:satMod val="135000"/>
+              </a:schemeClr>
+              <a:prstClr val="white"/>
+            </a:duotone>
+            <a:extLst>
+              <a:ext uri="{BEBA8EAE-BF5A-486C-A8C5-ECC9F3942E4B}">
+                <a14:imgProps xmlns:a14="http://schemas.microsoft.com/office/drawing/2010/main">
+                  <a14:imgLayer r:embed="rId9">
+                    <a14:imgEffect>
+                      <a14:colorTemperature colorTemp="4700"/>
+                    </a14:imgEffect>
+                    <a14:imgEffect>
+                      <a14:saturation sat="0"/>
+                    </a14:imgEffect>
+                  </a14:imgLayer>
+                </a14:imgProps>
+              </a:ext>
+            </a:extLst>
+          </a:blip>
+          <a:srcRect l="1287" t="17358" r="73201" b="14299"/>
+          <a:stretch>
+            <a:fillRect/>
+          </a:stretch>
+        </p:blipFill>
+        <p:spPr>
+          <a:xfrm rot="10800000">
+            <a:off x="11433373" y="6098266"/>
+            <a:ext cx="758627" cy="759734"/>
+          </a:xfrm>
+          <a:prstGeom prst="rect">
+            <a:avLst/>
+          </a:prstGeom>
+        </p:spPr>
+      </p:pic>
     </p:spTree>
     <p:extLst>
       <p:ext uri="{BB962C8B-B14F-4D97-AF65-F5344CB8AC3E}">
         <p14:creationId xmlns:p14="http://schemas.microsoft.com/office/powerpoint/2010/main" val="783618245"/>
+      </p:ext>
+    </p:extLst>
+  </p:cSld>
+  <p:clrMapOvr>
+    <a:masterClrMapping/>
+  </p:clrMapOvr>
+</p:sld>
+</file>
+
+<file path=ppt/slides/slide4.xml><?xml version="1.0" encoding="utf-8"?>
+<p:sld xmlns:a="http://schemas.openxmlformats.org/drawingml/2006/main" xmlns:r="http://schemas.openxmlformats.org/officeDocument/2006/relationships" xmlns:p="http://schemas.openxmlformats.org/presentationml/2006/main">
+  <p:cSld>
+    <p:spTree>
+      <p:nvGrpSpPr>
+        <p:cNvPr id="1" name="">
+          <a:extLst>
+            <a:ext uri="{FF2B5EF4-FFF2-40B4-BE49-F238E27FC236}">
+              <a16:creationId xmlns:a16="http://schemas.microsoft.com/office/drawing/2014/main" id="{CD291E6F-936F-C50D-5607-1ED8BF96E896}"/>
+            </a:ext>
+          </a:extLst>
+        </p:cNvPr>
+        <p:cNvGrpSpPr/>
+        <p:nvPr/>
+      </p:nvGrpSpPr>
+      <p:grpSpPr>
+        <a:xfrm>
+          <a:off x="0" y="0"/>
+          <a:ext cx="0" cy="0"/>
+          <a:chOff x="0" y="0"/>
+          <a:chExt cx="0" cy="0"/>
+        </a:xfrm>
+      </p:grpSpPr>
+      <p:pic>
+        <p:nvPicPr>
+          <p:cNvPr id="8" name="Image 7">
+            <a:extLst>
+              <a:ext uri="{FF2B5EF4-FFF2-40B4-BE49-F238E27FC236}">
+                <a16:creationId xmlns:a16="http://schemas.microsoft.com/office/drawing/2014/main" id="{1C178F77-15CC-6213-FB0A-628F039A828D}"/>
+              </a:ext>
+            </a:extLst>
+          </p:cNvPr>
+          <p:cNvPicPr>
+            <a:picLocks noChangeAspect="1"/>
+          </p:cNvPicPr>
+          <p:nvPr>
+            <p:custDataLst>
+              <p:tags r:id="rId1"/>
+            </p:custDataLst>
+          </p:nvPr>
+        </p:nvPicPr>
+        <p:blipFill>
+          <a:blip r:embed="rId7"/>
+          <a:srcRect l="4895" t="76969" r="85984"/>
+          <a:stretch>
+            <a:fillRect/>
+          </a:stretch>
+        </p:blipFill>
+        <p:spPr>
+          <a:xfrm>
+            <a:off x="0" y="0"/>
+            <a:ext cx="12192000" cy="6858000"/>
+          </a:xfrm>
+          <a:prstGeom prst="rect">
+            <a:avLst/>
+          </a:prstGeom>
+        </p:spPr>
+      </p:pic>
+      <p:sp>
+        <p:nvSpPr>
+          <p:cNvPr id="11" name="Rectangle 10">
+            <a:extLst>
+              <a:ext uri="{FF2B5EF4-FFF2-40B4-BE49-F238E27FC236}">
+                <a16:creationId xmlns:a16="http://schemas.microsoft.com/office/drawing/2014/main" id="{29D7E821-FB24-1053-968C-C1BB81B79C12}"/>
+              </a:ext>
+            </a:extLst>
+          </p:cNvPr>
+          <p:cNvSpPr/>
+          <p:nvPr>
+            <p:custDataLst>
+              <p:tags r:id="rId2"/>
+            </p:custDataLst>
+          </p:nvPr>
+        </p:nvSpPr>
+        <p:spPr>
+          <a:xfrm>
+            <a:off x="742334" y="986817"/>
+            <a:ext cx="10707329" cy="942792"/>
+          </a:xfrm>
+          <a:prstGeom prst="rect">
+            <a:avLst/>
+          </a:prstGeom>
+          <a:noFill/>
+          <a:ln>
+            <a:noFill/>
+          </a:ln>
+        </p:spPr>
+        <p:style>
+          <a:lnRef idx="2">
+            <a:schemeClr val="accent1">
+              <a:shade val="15000"/>
+            </a:schemeClr>
+          </a:lnRef>
+          <a:fillRef idx="1">
+            <a:schemeClr val="accent1"/>
+          </a:fillRef>
+          <a:effectRef idx="0">
+            <a:schemeClr val="accent1"/>
+          </a:effectRef>
+          <a:fontRef idx="minor">
+            <a:schemeClr val="lt1"/>
+          </a:fontRef>
+        </p:style>
+        <p:txBody>
+          <a:bodyPr rtlCol="0" anchor="ctr"/>
+          <a:lstStyle/>
+          <a:p>
+            <a:pPr algn="ctr"/>
+            <a:r>
+              <a:rPr lang="fr-CA" sz="3000" dirty="0">
+                <a:latin typeface="Pixel Operator 8" panose="02000503000000000000" pitchFamily="2" charset="0"/>
+              </a:rPr>
+              <a:t>Tips 3 :</a:t>
+            </a:r>
+          </a:p>
+        </p:txBody>
+      </p:sp>
+      <p:sp>
+        <p:nvSpPr>
+          <p:cNvPr id="2" name="Rectangle 1">
+            <a:extLst>
+              <a:ext uri="{FF2B5EF4-FFF2-40B4-BE49-F238E27FC236}">
+                <a16:creationId xmlns:a16="http://schemas.microsoft.com/office/drawing/2014/main" id="{887B0425-3291-A45A-6D34-C428D20876CD}"/>
+              </a:ext>
+            </a:extLst>
+          </p:cNvPr>
+          <p:cNvSpPr/>
+          <p:nvPr>
+            <p:custDataLst>
+              <p:tags r:id="rId3"/>
+            </p:custDataLst>
+          </p:nvPr>
+        </p:nvSpPr>
+        <p:spPr>
+          <a:xfrm>
+            <a:off x="742333" y="3190567"/>
+            <a:ext cx="10707329" cy="942792"/>
+          </a:xfrm>
+          <a:prstGeom prst="rect">
+            <a:avLst/>
+          </a:prstGeom>
+          <a:noFill/>
+          <a:ln>
+            <a:noFill/>
+          </a:ln>
+        </p:spPr>
+        <p:style>
+          <a:lnRef idx="2">
+            <a:schemeClr val="accent1">
+              <a:shade val="15000"/>
+            </a:schemeClr>
+          </a:lnRef>
+          <a:fillRef idx="1">
+            <a:schemeClr val="accent1"/>
+          </a:fillRef>
+          <a:effectRef idx="0">
+            <a:schemeClr val="accent1"/>
+          </a:effectRef>
+          <a:fontRef idx="minor">
+            <a:schemeClr val="lt1"/>
+          </a:fontRef>
+        </p:style>
+        <p:txBody>
+          <a:bodyPr rtlCol="0" anchor="ctr"/>
+          <a:lstStyle/>
+          <a:p>
+            <a:pPr algn="ctr"/>
+            <a:r>
+              <a:rPr lang="fr-CA" sz="3000" dirty="0">
+                <a:latin typeface="Pixel Operator 8" panose="02000503000000000000" pitchFamily="2" charset="0"/>
+              </a:rPr>
+              <a:t>Don’t die!</a:t>
+            </a:r>
+          </a:p>
+        </p:txBody>
+      </p:sp>
+      <p:sp>
+        <p:nvSpPr>
+          <p:cNvPr id="3" name="Rectangle 2">
+            <a:extLst>
+              <a:ext uri="{FF2B5EF4-FFF2-40B4-BE49-F238E27FC236}">
+                <a16:creationId xmlns:a16="http://schemas.microsoft.com/office/drawing/2014/main" id="{135BEF50-F036-1CC2-0E4B-1FE7AE39D074}"/>
+              </a:ext>
+            </a:extLst>
+          </p:cNvPr>
+          <p:cNvSpPr/>
+          <p:nvPr>
+            <p:custDataLst>
+              <p:tags r:id="rId4"/>
+            </p:custDataLst>
+          </p:nvPr>
+        </p:nvSpPr>
+        <p:spPr>
+          <a:xfrm>
+            <a:off x="245806" y="403123"/>
+            <a:ext cx="11759381" cy="6194321"/>
+          </a:xfrm>
+          <a:prstGeom prst="rect">
+            <a:avLst/>
+          </a:prstGeom>
+          <a:noFill/>
+          <a:ln>
+            <a:solidFill>
+              <a:schemeClr val="bg1"/>
+            </a:solidFill>
+          </a:ln>
+        </p:spPr>
+        <p:style>
+          <a:lnRef idx="2">
+            <a:schemeClr val="accent1">
+              <a:shade val="15000"/>
+            </a:schemeClr>
+          </a:lnRef>
+          <a:fillRef idx="1">
+            <a:schemeClr val="accent1"/>
+          </a:fillRef>
+          <a:effectRef idx="0">
+            <a:schemeClr val="accent1"/>
+          </a:effectRef>
+          <a:fontRef idx="minor">
+            <a:schemeClr val="lt1"/>
+          </a:fontRef>
+        </p:style>
+        <p:txBody>
+          <a:bodyPr rtlCol="0" anchor="ctr"/>
+          <a:lstStyle/>
+          <a:p>
+            <a:pPr algn="ctr"/>
+            <a:endParaRPr lang="fr-CA"/>
+          </a:p>
+        </p:txBody>
+      </p:sp>
+      <p:pic>
+        <p:nvPicPr>
+          <p:cNvPr id="7" name="Image 6">
+            <a:extLst>
+              <a:ext uri="{FF2B5EF4-FFF2-40B4-BE49-F238E27FC236}">
+                <a16:creationId xmlns:a16="http://schemas.microsoft.com/office/drawing/2014/main" id="{0AA2A07E-182A-7B20-6067-7ABAD6DE6A3D}"/>
+              </a:ext>
+            </a:extLst>
+          </p:cNvPr>
+          <p:cNvPicPr>
+            <a:picLocks noChangeAspect="1"/>
+          </p:cNvPicPr>
+          <p:nvPr>
+            <p:custDataLst>
+              <p:tags r:id="rId5"/>
+            </p:custDataLst>
+          </p:nvPr>
+        </p:nvPicPr>
+        <p:blipFill>
+          <a:blip r:embed="rId7"/>
+          <a:srcRect l="4895" r="4092"/>
+          <a:stretch>
+            <a:fillRect/>
+          </a:stretch>
+        </p:blipFill>
+        <p:spPr>
+          <a:xfrm>
+            <a:off x="3864077" y="0"/>
+            <a:ext cx="4463845" cy="1053879"/>
+          </a:xfrm>
+          <a:prstGeom prst="rect">
+            <a:avLst/>
+          </a:prstGeom>
+        </p:spPr>
+      </p:pic>
+      <p:pic>
+        <p:nvPicPr>
+          <p:cNvPr id="4" name="Image 3">
+            <a:extLst>
+              <a:ext uri="{FF2B5EF4-FFF2-40B4-BE49-F238E27FC236}">
+                <a16:creationId xmlns:a16="http://schemas.microsoft.com/office/drawing/2014/main" id="{0D0492BC-A164-CEE9-7FDF-5FAA8C767E98}"/>
+              </a:ext>
+            </a:extLst>
+          </p:cNvPr>
+          <p:cNvPicPr>
+            <a:picLocks noChangeAspect="1"/>
+          </p:cNvPicPr>
+          <p:nvPr/>
+        </p:nvPicPr>
+        <p:blipFill>
+          <a:blip r:embed="rId8">
+            <a:duotone>
+              <a:schemeClr val="bg2">
+                <a:shade val="45000"/>
+                <a:satMod val="135000"/>
+              </a:schemeClr>
+              <a:prstClr val="white"/>
+            </a:duotone>
+            <a:extLst>
+              <a:ext uri="{BEBA8EAE-BF5A-486C-A8C5-ECC9F3942E4B}">
+                <a14:imgProps xmlns:a14="http://schemas.microsoft.com/office/drawing/2010/main">
+                  <a14:imgLayer r:embed="rId9">
+                    <a14:imgEffect>
+                      <a14:colorTemperature colorTemp="4700"/>
+                    </a14:imgEffect>
+                    <a14:imgEffect>
+                      <a14:saturation sat="0"/>
+                    </a14:imgEffect>
+                  </a14:imgLayer>
+                </a14:imgProps>
+              </a:ext>
+            </a:extLst>
+          </a:blip>
+          <a:srcRect l="1287" t="17358" r="73201" b="14299"/>
+          <a:stretch>
+            <a:fillRect/>
+          </a:stretch>
+        </p:blipFill>
+        <p:spPr>
+          <a:xfrm>
+            <a:off x="0" y="6098266"/>
+            <a:ext cx="758627" cy="759734"/>
+          </a:xfrm>
+          <a:prstGeom prst="rect">
+            <a:avLst/>
+          </a:prstGeom>
+        </p:spPr>
+      </p:pic>
+      <p:pic>
+        <p:nvPicPr>
+          <p:cNvPr id="5" name="Image 4">
+            <a:extLst>
+              <a:ext uri="{FF2B5EF4-FFF2-40B4-BE49-F238E27FC236}">
+                <a16:creationId xmlns:a16="http://schemas.microsoft.com/office/drawing/2014/main" id="{6B4C67AE-EF19-5421-E639-791FC4BC4384}"/>
+              </a:ext>
+            </a:extLst>
+          </p:cNvPr>
+          <p:cNvPicPr>
+            <a:picLocks noChangeAspect="1"/>
+          </p:cNvPicPr>
+          <p:nvPr/>
+        </p:nvPicPr>
+        <p:blipFill>
+          <a:blip r:embed="rId8">
+            <a:duotone>
+              <a:schemeClr val="bg2">
+                <a:shade val="45000"/>
+                <a:satMod val="135000"/>
+              </a:schemeClr>
+              <a:prstClr val="white"/>
+            </a:duotone>
+            <a:extLst>
+              <a:ext uri="{BEBA8EAE-BF5A-486C-A8C5-ECC9F3942E4B}">
+                <a14:imgProps xmlns:a14="http://schemas.microsoft.com/office/drawing/2010/main">
+                  <a14:imgLayer r:embed="rId9">
+                    <a14:imgEffect>
+                      <a14:colorTemperature colorTemp="4700"/>
+                    </a14:imgEffect>
+                    <a14:imgEffect>
+                      <a14:saturation sat="0"/>
+                    </a14:imgEffect>
+                  </a14:imgLayer>
+                </a14:imgProps>
+              </a:ext>
+            </a:extLst>
+          </a:blip>
+          <a:srcRect l="1287" t="17358" r="73201" b="14299"/>
+          <a:stretch>
+            <a:fillRect/>
+          </a:stretch>
+        </p:blipFill>
+        <p:spPr>
+          <a:xfrm rot="10800000">
+            <a:off x="11433373" y="6098266"/>
+            <a:ext cx="758627" cy="759734"/>
+          </a:xfrm>
+          <a:prstGeom prst="rect">
+            <a:avLst/>
+          </a:prstGeom>
+        </p:spPr>
+      </p:pic>
+    </p:spTree>
+    <p:extLst>
+      <p:ext uri="{BB962C8B-B14F-4D97-AF65-F5344CB8AC3E}">
+        <p14:creationId xmlns:p14="http://schemas.microsoft.com/office/powerpoint/2010/main" val="3791610"/>
+      </p:ext>
+    </p:extLst>
+  </p:cSld>
+  <p:clrMapOvr>
+    <a:masterClrMapping/>
+  </p:clrMapOvr>
+</p:sld>
+</file>
+
+<file path=ppt/slides/slide5.xml><?xml version="1.0" encoding="utf-8"?>
+<p:sld xmlns:a="http://schemas.openxmlformats.org/drawingml/2006/main" xmlns:r="http://schemas.openxmlformats.org/officeDocument/2006/relationships" xmlns:p="http://schemas.openxmlformats.org/presentationml/2006/main">
+  <p:cSld>
+    <p:spTree>
+      <p:nvGrpSpPr>
+        <p:cNvPr id="1" name="">
+          <a:extLst>
+            <a:ext uri="{FF2B5EF4-FFF2-40B4-BE49-F238E27FC236}">
+              <a16:creationId xmlns:a16="http://schemas.microsoft.com/office/drawing/2014/main" id="{E577B2E2-4950-183C-6983-FDF58272EB7E}"/>
+            </a:ext>
+          </a:extLst>
+        </p:cNvPr>
+        <p:cNvGrpSpPr/>
+        <p:nvPr/>
+      </p:nvGrpSpPr>
+      <p:grpSpPr>
+        <a:xfrm>
+          <a:off x="0" y="0"/>
+          <a:ext cx="0" cy="0"/>
+          <a:chOff x="0" y="0"/>
+          <a:chExt cx="0" cy="0"/>
+        </a:xfrm>
+      </p:grpSpPr>
+      <p:pic>
+        <p:nvPicPr>
+          <p:cNvPr id="8" name="Image 7">
+            <a:extLst>
+              <a:ext uri="{FF2B5EF4-FFF2-40B4-BE49-F238E27FC236}">
+                <a16:creationId xmlns:a16="http://schemas.microsoft.com/office/drawing/2014/main" id="{52645CC1-EB29-566D-D877-2807E5670FAA}"/>
+              </a:ext>
+            </a:extLst>
+          </p:cNvPr>
+          <p:cNvPicPr>
+            <a:picLocks noChangeAspect="1"/>
+          </p:cNvPicPr>
+          <p:nvPr>
+            <p:custDataLst>
+              <p:tags r:id="rId1"/>
+            </p:custDataLst>
+          </p:nvPr>
+        </p:nvPicPr>
+        <p:blipFill>
+          <a:blip r:embed="rId7"/>
+          <a:srcRect l="4895" t="76969" r="85984"/>
+          <a:stretch>
+            <a:fillRect/>
+          </a:stretch>
+        </p:blipFill>
+        <p:spPr>
+          <a:xfrm>
+            <a:off x="0" y="0"/>
+            <a:ext cx="12192000" cy="6858000"/>
+          </a:xfrm>
+          <a:prstGeom prst="rect">
+            <a:avLst/>
+          </a:prstGeom>
+        </p:spPr>
+      </p:pic>
+      <p:sp>
+        <p:nvSpPr>
+          <p:cNvPr id="11" name="Rectangle 10">
+            <a:extLst>
+              <a:ext uri="{FF2B5EF4-FFF2-40B4-BE49-F238E27FC236}">
+                <a16:creationId xmlns:a16="http://schemas.microsoft.com/office/drawing/2014/main" id="{DC64A7FB-0409-A059-DFEF-EB6CFFFE521A}"/>
+              </a:ext>
+            </a:extLst>
+          </p:cNvPr>
+          <p:cNvSpPr/>
+          <p:nvPr>
+            <p:custDataLst>
+              <p:tags r:id="rId2"/>
+            </p:custDataLst>
+          </p:nvPr>
+        </p:nvSpPr>
+        <p:spPr>
+          <a:xfrm>
+            <a:off x="742334" y="986817"/>
+            <a:ext cx="10707329" cy="942792"/>
+          </a:xfrm>
+          <a:prstGeom prst="rect">
+            <a:avLst/>
+          </a:prstGeom>
+          <a:noFill/>
+          <a:ln>
+            <a:noFill/>
+          </a:ln>
+        </p:spPr>
+        <p:style>
+          <a:lnRef idx="2">
+            <a:schemeClr val="accent1">
+              <a:shade val="15000"/>
+            </a:schemeClr>
+          </a:lnRef>
+          <a:fillRef idx="1">
+            <a:schemeClr val="accent1"/>
+          </a:fillRef>
+          <a:effectRef idx="0">
+            <a:schemeClr val="accent1"/>
+          </a:effectRef>
+          <a:fontRef idx="minor">
+            <a:schemeClr val="lt1"/>
+          </a:fontRef>
+        </p:style>
+        <p:txBody>
+          <a:bodyPr rtlCol="0" anchor="ctr"/>
+          <a:lstStyle/>
+          <a:p>
+            <a:pPr algn="ctr"/>
+            <a:r>
+              <a:rPr lang="fr-CA" sz="3000" dirty="0">
+                <a:latin typeface="Pixel Operator 8" panose="02000503000000000000" pitchFamily="2" charset="0"/>
+              </a:rPr>
+              <a:t>Tips 4 :</a:t>
+            </a:r>
+          </a:p>
+        </p:txBody>
+      </p:sp>
+      <p:sp>
+        <p:nvSpPr>
+          <p:cNvPr id="2" name="Rectangle 1">
+            <a:extLst>
+              <a:ext uri="{FF2B5EF4-FFF2-40B4-BE49-F238E27FC236}">
+                <a16:creationId xmlns:a16="http://schemas.microsoft.com/office/drawing/2014/main" id="{5F3C79D1-6A64-236B-50A9-7B4400A8A9E3}"/>
+              </a:ext>
+            </a:extLst>
+          </p:cNvPr>
+          <p:cNvSpPr/>
+          <p:nvPr>
+            <p:custDataLst>
+              <p:tags r:id="rId3"/>
+            </p:custDataLst>
+          </p:nvPr>
+        </p:nvSpPr>
+        <p:spPr>
+          <a:xfrm>
+            <a:off x="742333" y="3190567"/>
+            <a:ext cx="10707329" cy="942792"/>
+          </a:xfrm>
+          <a:prstGeom prst="rect">
+            <a:avLst/>
+          </a:prstGeom>
+          <a:noFill/>
+          <a:ln>
+            <a:noFill/>
+          </a:ln>
+        </p:spPr>
+        <p:style>
+          <a:lnRef idx="2">
+            <a:schemeClr val="accent1">
+              <a:shade val="15000"/>
+            </a:schemeClr>
+          </a:lnRef>
+          <a:fillRef idx="1">
+            <a:schemeClr val="accent1"/>
+          </a:fillRef>
+          <a:effectRef idx="0">
+            <a:schemeClr val="accent1"/>
+          </a:effectRef>
+          <a:fontRef idx="minor">
+            <a:schemeClr val="lt1"/>
+          </a:fontRef>
+        </p:style>
+        <p:txBody>
+          <a:bodyPr rtlCol="0" anchor="ctr"/>
+          <a:lstStyle/>
+          <a:p>
+            <a:pPr algn="ctr"/>
+            <a:r>
+              <a:rPr lang="fr-CA" sz="3000" dirty="0">
+                <a:latin typeface="Pixel Operator 8" panose="02000503000000000000" pitchFamily="2" charset="0"/>
+              </a:rPr>
+              <a:t>Have fun!</a:t>
+            </a:r>
+          </a:p>
+        </p:txBody>
+      </p:sp>
+      <p:sp>
+        <p:nvSpPr>
+          <p:cNvPr id="3" name="Rectangle 2">
+            <a:extLst>
+              <a:ext uri="{FF2B5EF4-FFF2-40B4-BE49-F238E27FC236}">
+                <a16:creationId xmlns:a16="http://schemas.microsoft.com/office/drawing/2014/main" id="{5CBFC61A-C578-CF40-EC39-9A1F80DAB451}"/>
+              </a:ext>
+            </a:extLst>
+          </p:cNvPr>
+          <p:cNvSpPr/>
+          <p:nvPr>
+            <p:custDataLst>
+              <p:tags r:id="rId4"/>
+            </p:custDataLst>
+          </p:nvPr>
+        </p:nvSpPr>
+        <p:spPr>
+          <a:xfrm>
+            <a:off x="245806" y="403123"/>
+            <a:ext cx="11759381" cy="6194321"/>
+          </a:xfrm>
+          <a:prstGeom prst="rect">
+            <a:avLst/>
+          </a:prstGeom>
+          <a:noFill/>
+          <a:ln>
+            <a:solidFill>
+              <a:schemeClr val="bg1"/>
+            </a:solidFill>
+          </a:ln>
+        </p:spPr>
+        <p:style>
+          <a:lnRef idx="2">
+            <a:schemeClr val="accent1">
+              <a:shade val="15000"/>
+            </a:schemeClr>
+          </a:lnRef>
+          <a:fillRef idx="1">
+            <a:schemeClr val="accent1"/>
+          </a:fillRef>
+          <a:effectRef idx="0">
+            <a:schemeClr val="accent1"/>
+          </a:effectRef>
+          <a:fontRef idx="minor">
+            <a:schemeClr val="lt1"/>
+          </a:fontRef>
+        </p:style>
+        <p:txBody>
+          <a:bodyPr rtlCol="0" anchor="ctr"/>
+          <a:lstStyle/>
+          <a:p>
+            <a:pPr algn="ctr"/>
+            <a:endParaRPr lang="fr-CA"/>
+          </a:p>
+        </p:txBody>
+      </p:sp>
+      <p:pic>
+        <p:nvPicPr>
+          <p:cNvPr id="7" name="Image 6">
+            <a:extLst>
+              <a:ext uri="{FF2B5EF4-FFF2-40B4-BE49-F238E27FC236}">
+                <a16:creationId xmlns:a16="http://schemas.microsoft.com/office/drawing/2014/main" id="{D87CA475-BA23-6115-A8A3-F467B24BE35D}"/>
+              </a:ext>
+            </a:extLst>
+          </p:cNvPr>
+          <p:cNvPicPr>
+            <a:picLocks noChangeAspect="1"/>
+          </p:cNvPicPr>
+          <p:nvPr>
+            <p:custDataLst>
+              <p:tags r:id="rId5"/>
+            </p:custDataLst>
+          </p:nvPr>
+        </p:nvPicPr>
+        <p:blipFill>
+          <a:blip r:embed="rId7"/>
+          <a:srcRect l="4895" r="4092"/>
+          <a:stretch>
+            <a:fillRect/>
+          </a:stretch>
+        </p:blipFill>
+        <p:spPr>
+          <a:xfrm>
+            <a:off x="3864077" y="0"/>
+            <a:ext cx="4463845" cy="1053879"/>
+          </a:xfrm>
+          <a:prstGeom prst="rect">
+            <a:avLst/>
+          </a:prstGeom>
+        </p:spPr>
+      </p:pic>
+      <p:pic>
+        <p:nvPicPr>
+          <p:cNvPr id="4" name="Image 3">
+            <a:extLst>
+              <a:ext uri="{FF2B5EF4-FFF2-40B4-BE49-F238E27FC236}">
+                <a16:creationId xmlns:a16="http://schemas.microsoft.com/office/drawing/2014/main" id="{F8326669-0691-0B5D-AE82-CF3D92B1F73D}"/>
+              </a:ext>
+            </a:extLst>
+          </p:cNvPr>
+          <p:cNvPicPr>
+            <a:picLocks noChangeAspect="1"/>
+          </p:cNvPicPr>
+          <p:nvPr/>
+        </p:nvPicPr>
+        <p:blipFill>
+          <a:blip r:embed="rId8">
+            <a:duotone>
+              <a:schemeClr val="bg2">
+                <a:shade val="45000"/>
+                <a:satMod val="135000"/>
+              </a:schemeClr>
+              <a:prstClr val="white"/>
+            </a:duotone>
+            <a:extLst>
+              <a:ext uri="{BEBA8EAE-BF5A-486C-A8C5-ECC9F3942E4B}">
+                <a14:imgProps xmlns:a14="http://schemas.microsoft.com/office/drawing/2010/main">
+                  <a14:imgLayer r:embed="rId9">
+                    <a14:imgEffect>
+                      <a14:colorTemperature colorTemp="4700"/>
+                    </a14:imgEffect>
+                    <a14:imgEffect>
+                      <a14:saturation sat="0"/>
+                    </a14:imgEffect>
+                  </a14:imgLayer>
+                </a14:imgProps>
+              </a:ext>
+            </a:extLst>
+          </a:blip>
+          <a:srcRect l="1287" t="17358" r="73201" b="14299"/>
+          <a:stretch>
+            <a:fillRect/>
+          </a:stretch>
+        </p:blipFill>
+        <p:spPr>
+          <a:xfrm>
+            <a:off x="0" y="6098266"/>
+            <a:ext cx="758627" cy="759734"/>
+          </a:xfrm>
+          <a:prstGeom prst="rect">
+            <a:avLst/>
+          </a:prstGeom>
+        </p:spPr>
+      </p:pic>
+    </p:spTree>
+    <p:extLst>
+      <p:ext uri="{BB962C8B-B14F-4D97-AF65-F5344CB8AC3E}">
+        <p14:creationId xmlns:p14="http://schemas.microsoft.com/office/powerpoint/2010/main" val="2741105540"/>
       </p:ext>
     </p:extLst>
   </p:cSld>
@@ -4921,9 +5907,69 @@
 </p:tagLst>
 </file>
 
+<file path=ppt/tags/tag22.xml><?xml version="1.0" encoding="utf-8"?>
+<p:tagLst xmlns:a="http://schemas.openxmlformats.org/drawingml/2006/main" xmlns:r="http://schemas.openxmlformats.org/officeDocument/2006/relationships" xmlns:p="http://schemas.openxmlformats.org/presentationml/2006/main">
+  <p:tag name="NUM" val="1"/>
+</p:tagLst>
+</file>
+
+<file path=ppt/tags/tag23.xml><?xml version="1.0" encoding="utf-8"?>
+<p:tagLst xmlns:a="http://schemas.openxmlformats.org/drawingml/2006/main" xmlns:r="http://schemas.openxmlformats.org/officeDocument/2006/relationships" xmlns:p="http://schemas.openxmlformats.org/presentationml/2006/main">
+  <p:tag name="NUM" val="2"/>
+</p:tagLst>
+</file>
+
+<file path=ppt/tags/tag24.xml><?xml version="1.0" encoding="utf-8"?>
+<p:tagLst xmlns:a="http://schemas.openxmlformats.org/drawingml/2006/main" xmlns:r="http://schemas.openxmlformats.org/officeDocument/2006/relationships" xmlns:p="http://schemas.openxmlformats.org/presentationml/2006/main">
+  <p:tag name="NUM" val="3"/>
+</p:tagLst>
+</file>
+
+<file path=ppt/tags/tag25.xml><?xml version="1.0" encoding="utf-8"?>
+<p:tagLst xmlns:a="http://schemas.openxmlformats.org/drawingml/2006/main" xmlns:r="http://schemas.openxmlformats.org/officeDocument/2006/relationships" xmlns:p="http://schemas.openxmlformats.org/presentationml/2006/main">
+  <p:tag name="NUM" val="4"/>
+</p:tagLst>
+</file>
+
+<file path=ppt/tags/tag26.xml><?xml version="1.0" encoding="utf-8"?>
+<p:tagLst xmlns:a="http://schemas.openxmlformats.org/drawingml/2006/main" xmlns:r="http://schemas.openxmlformats.org/officeDocument/2006/relationships" xmlns:p="http://schemas.openxmlformats.org/presentationml/2006/main">
+  <p:tag name="NUM" val="5"/>
+</p:tagLst>
+</file>
+
+<file path=ppt/tags/tag27.xml><?xml version="1.0" encoding="utf-8"?>
+<p:tagLst xmlns:a="http://schemas.openxmlformats.org/drawingml/2006/main" xmlns:r="http://schemas.openxmlformats.org/officeDocument/2006/relationships" xmlns:p="http://schemas.openxmlformats.org/presentationml/2006/main">
+  <p:tag name="NUM" val="1"/>
+</p:tagLst>
+</file>
+
+<file path=ppt/tags/tag28.xml><?xml version="1.0" encoding="utf-8"?>
+<p:tagLst xmlns:a="http://schemas.openxmlformats.org/drawingml/2006/main" xmlns:r="http://schemas.openxmlformats.org/officeDocument/2006/relationships" xmlns:p="http://schemas.openxmlformats.org/presentationml/2006/main">
+  <p:tag name="NUM" val="2"/>
+</p:tagLst>
+</file>
+
+<file path=ppt/tags/tag29.xml><?xml version="1.0" encoding="utf-8"?>
+<p:tagLst xmlns:a="http://schemas.openxmlformats.org/drawingml/2006/main" xmlns:r="http://schemas.openxmlformats.org/officeDocument/2006/relationships" xmlns:p="http://schemas.openxmlformats.org/presentationml/2006/main">
+  <p:tag name="NUM" val="3"/>
+</p:tagLst>
+</file>
+
 <file path=ppt/tags/tag3.xml><?xml version="1.0" encoding="utf-8"?>
 <p:tagLst xmlns:a="http://schemas.openxmlformats.org/drawingml/2006/main" xmlns:r="http://schemas.openxmlformats.org/officeDocument/2006/relationships" xmlns:p="http://schemas.openxmlformats.org/presentationml/2006/main">
   <p:tag name="NUM" val="3"/>
+</p:tagLst>
+</file>
+
+<file path=ppt/tags/tag30.xml><?xml version="1.0" encoding="utf-8"?>
+<p:tagLst xmlns:a="http://schemas.openxmlformats.org/drawingml/2006/main" xmlns:r="http://schemas.openxmlformats.org/officeDocument/2006/relationships" xmlns:p="http://schemas.openxmlformats.org/presentationml/2006/main">
+  <p:tag name="NUM" val="4"/>
+</p:tagLst>
+</file>
+
+<file path=ppt/tags/tag31.xml><?xml version="1.0" encoding="utf-8"?>
+<p:tagLst xmlns:a="http://schemas.openxmlformats.org/drawingml/2006/main" xmlns:r="http://schemas.openxmlformats.org/officeDocument/2006/relationships" xmlns:p="http://schemas.openxmlformats.org/presentationml/2006/main">
+  <p:tag name="NUM" val="5"/>
 </p:tagLst>
 </file>
 

</xml_diff>

<commit_message>
Added credits and remove help (replaced by new tutorial page)
</commit_message>
<xml_diff>
--- a/images/drawingTheTutorial.pptx
+++ b/images/drawingTheTutorial.pptx
@@ -6,10 +6,11 @@
   </p:sldMasterIdLst>
   <p:sldIdLst>
     <p:sldId id="256" r:id="rId2"/>
-    <p:sldId id="257" r:id="rId3"/>
-    <p:sldId id="259" r:id="rId4"/>
-    <p:sldId id="260" r:id="rId5"/>
-    <p:sldId id="261" r:id="rId6"/>
+    <p:sldId id="262" r:id="rId3"/>
+    <p:sldId id="257" r:id="rId4"/>
+    <p:sldId id="259" r:id="rId5"/>
+    <p:sldId id="260" r:id="rId6"/>
+    <p:sldId id="261" r:id="rId7"/>
   </p:sldIdLst>
   <p:sldSz cx="12192000" cy="6858000"/>
   <p:notesSz cx="6858000" cy="9144000"/>
@@ -265,7 +266,7 @@
           <a:p>
             <a:fld id="{7D80224B-D26D-4BBF-93A6-090E4F9F4A69}" type="datetimeFigureOut">
               <a:rPr lang="fr-CA" smtClean="0"/>
-              <a:t>2026-05-05</a:t>
+              <a:t>2026-05-11</a:t>
             </a:fld>
             <a:endParaRPr lang="fr-CA"/>
           </a:p>
@@ -465,7 +466,7 @@
           <a:p>
             <a:fld id="{7D80224B-D26D-4BBF-93A6-090E4F9F4A69}" type="datetimeFigureOut">
               <a:rPr lang="fr-CA" smtClean="0"/>
-              <a:t>2026-05-05</a:t>
+              <a:t>2026-05-11</a:t>
             </a:fld>
             <a:endParaRPr lang="fr-CA"/>
           </a:p>
@@ -675,7 +676,7 @@
           <a:p>
             <a:fld id="{7D80224B-D26D-4BBF-93A6-090E4F9F4A69}" type="datetimeFigureOut">
               <a:rPr lang="fr-CA" smtClean="0"/>
-              <a:t>2026-05-05</a:t>
+              <a:t>2026-05-11</a:t>
             </a:fld>
             <a:endParaRPr lang="fr-CA"/>
           </a:p>
@@ -875,7 +876,7 @@
           <a:p>
             <a:fld id="{7D80224B-D26D-4BBF-93A6-090E4F9F4A69}" type="datetimeFigureOut">
               <a:rPr lang="fr-CA" smtClean="0"/>
-              <a:t>2026-05-05</a:t>
+              <a:t>2026-05-11</a:t>
             </a:fld>
             <a:endParaRPr lang="fr-CA"/>
           </a:p>
@@ -1151,7 +1152,7 @@
           <a:p>
             <a:fld id="{7D80224B-D26D-4BBF-93A6-090E4F9F4A69}" type="datetimeFigureOut">
               <a:rPr lang="fr-CA" smtClean="0"/>
-              <a:t>2026-05-05</a:t>
+              <a:t>2026-05-11</a:t>
             </a:fld>
             <a:endParaRPr lang="fr-CA"/>
           </a:p>
@@ -1419,7 +1420,7 @@
           <a:p>
             <a:fld id="{7D80224B-D26D-4BBF-93A6-090E4F9F4A69}" type="datetimeFigureOut">
               <a:rPr lang="fr-CA" smtClean="0"/>
-              <a:t>2026-05-05</a:t>
+              <a:t>2026-05-11</a:t>
             </a:fld>
             <a:endParaRPr lang="fr-CA"/>
           </a:p>
@@ -1834,7 +1835,7 @@
           <a:p>
             <a:fld id="{7D80224B-D26D-4BBF-93A6-090E4F9F4A69}" type="datetimeFigureOut">
               <a:rPr lang="fr-CA" smtClean="0"/>
-              <a:t>2026-05-05</a:t>
+              <a:t>2026-05-11</a:t>
             </a:fld>
             <a:endParaRPr lang="fr-CA"/>
           </a:p>
@@ -1976,7 +1977,7 @@
           <a:p>
             <a:fld id="{7D80224B-D26D-4BBF-93A6-090E4F9F4A69}" type="datetimeFigureOut">
               <a:rPr lang="fr-CA" smtClean="0"/>
-              <a:t>2026-05-05</a:t>
+              <a:t>2026-05-11</a:t>
             </a:fld>
             <a:endParaRPr lang="fr-CA"/>
           </a:p>
@@ -2089,7 +2090,7 @@
           <a:p>
             <a:fld id="{7D80224B-D26D-4BBF-93A6-090E4F9F4A69}" type="datetimeFigureOut">
               <a:rPr lang="fr-CA" smtClean="0"/>
-              <a:t>2026-05-05</a:t>
+              <a:t>2026-05-11</a:t>
             </a:fld>
             <a:endParaRPr lang="fr-CA"/>
           </a:p>
@@ -2402,7 +2403,7 @@
           <a:p>
             <a:fld id="{7D80224B-D26D-4BBF-93A6-090E4F9F4A69}" type="datetimeFigureOut">
               <a:rPr lang="fr-CA" smtClean="0"/>
-              <a:t>2026-05-05</a:t>
+              <a:t>2026-05-11</a:t>
             </a:fld>
             <a:endParaRPr lang="fr-CA"/>
           </a:p>
@@ -2691,7 +2692,7 @@
           <a:p>
             <a:fld id="{7D80224B-D26D-4BBF-93A6-090E4F9F4A69}" type="datetimeFigureOut">
               <a:rPr lang="fr-CA" smtClean="0"/>
-              <a:t>2026-05-05</a:t>
+              <a:t>2026-05-11</a:t>
             </a:fld>
             <a:endParaRPr lang="fr-CA"/>
           </a:p>
@@ -2934,7 +2935,7 @@
           <a:p>
             <a:fld id="{7D80224B-D26D-4BBF-93A6-090E4F9F4A69}" type="datetimeFigureOut">
               <a:rPr lang="fr-CA" smtClean="0"/>
-              <a:t>2026-05-05</a:t>
+              <a:t>2026-05-11</a:t>
             </a:fld>
             <a:endParaRPr lang="fr-CA"/>
           </a:p>
@@ -4187,6 +4188,530 @@
         <p:cNvPr id="1" name="">
           <a:extLst>
             <a:ext uri="{FF2B5EF4-FFF2-40B4-BE49-F238E27FC236}">
+              <a16:creationId xmlns:a16="http://schemas.microsoft.com/office/drawing/2014/main" id="{C7BD4F38-39F0-4CF6-EE84-9BAEEED795D7}"/>
+            </a:ext>
+          </a:extLst>
+        </p:cNvPr>
+        <p:cNvGrpSpPr/>
+        <p:nvPr/>
+      </p:nvGrpSpPr>
+      <p:grpSpPr>
+        <a:xfrm>
+          <a:off x="0" y="0"/>
+          <a:ext cx="0" cy="0"/>
+          <a:chOff x="0" y="0"/>
+          <a:chExt cx="0" cy="0"/>
+        </a:xfrm>
+      </p:grpSpPr>
+      <p:pic>
+        <p:nvPicPr>
+          <p:cNvPr id="8" name="Image 7">
+            <a:extLst>
+              <a:ext uri="{FF2B5EF4-FFF2-40B4-BE49-F238E27FC236}">
+                <a16:creationId xmlns:a16="http://schemas.microsoft.com/office/drawing/2014/main" id="{4BD4EA85-125D-7331-B828-DA4B650E7316}"/>
+              </a:ext>
+            </a:extLst>
+          </p:cNvPr>
+          <p:cNvPicPr>
+            <a:picLocks noChangeAspect="1"/>
+          </p:cNvPicPr>
+          <p:nvPr>
+            <p:custDataLst>
+              <p:tags r:id="rId1"/>
+            </p:custDataLst>
+          </p:nvPr>
+        </p:nvPicPr>
+        <p:blipFill>
+          <a:blip r:embed="rId9"/>
+          <a:srcRect l="4895" t="76969" r="85984"/>
+          <a:stretch>
+            <a:fillRect/>
+          </a:stretch>
+        </p:blipFill>
+        <p:spPr>
+          <a:xfrm>
+            <a:off x="0" y="0"/>
+            <a:ext cx="12192000" cy="6858000"/>
+          </a:xfrm>
+          <a:prstGeom prst="rect">
+            <a:avLst/>
+          </a:prstGeom>
+        </p:spPr>
+      </p:pic>
+      <p:sp>
+        <p:nvSpPr>
+          <p:cNvPr id="2" name="Rectangle 1">
+            <a:extLst>
+              <a:ext uri="{FF2B5EF4-FFF2-40B4-BE49-F238E27FC236}">
+                <a16:creationId xmlns:a16="http://schemas.microsoft.com/office/drawing/2014/main" id="{2F2EB0FA-36B8-4604-A6C5-4F8D50805700}"/>
+              </a:ext>
+            </a:extLst>
+          </p:cNvPr>
+          <p:cNvSpPr/>
+          <p:nvPr>
+            <p:custDataLst>
+              <p:tags r:id="rId2"/>
+            </p:custDataLst>
+          </p:nvPr>
+        </p:nvSpPr>
+        <p:spPr>
+          <a:xfrm>
+            <a:off x="345817" y="1086240"/>
+            <a:ext cx="11500363" cy="4828086"/>
+          </a:xfrm>
+          <a:prstGeom prst="rect">
+            <a:avLst/>
+          </a:prstGeom>
+          <a:noFill/>
+          <a:ln>
+            <a:noFill/>
+          </a:ln>
+        </p:spPr>
+        <p:style>
+          <a:lnRef idx="2">
+            <a:schemeClr val="accent1">
+              <a:shade val="15000"/>
+            </a:schemeClr>
+          </a:lnRef>
+          <a:fillRef idx="1">
+            <a:schemeClr val="accent1"/>
+          </a:fillRef>
+          <a:effectRef idx="0">
+            <a:schemeClr val="accent1"/>
+          </a:effectRef>
+          <a:fontRef idx="minor">
+            <a:schemeClr val="lt1"/>
+          </a:fontRef>
+        </p:style>
+        <p:txBody>
+          <a:bodyPr rtlCol="0" anchor="ctr"/>
+          <a:lstStyle/>
+          <a:p>
+            <a:pPr algn="ctr"/>
+            <a:r>
+              <a:rPr lang="en-US" sz="3000" dirty="0">
+                <a:latin typeface="Pixel Operator 8" panose="02000503000000000000" pitchFamily="2" charset="0"/>
+              </a:rPr>
+              <a:t>Use the arrow keys to move. </a:t>
+            </a:r>
+          </a:p>
+          <a:p>
+            <a:pPr algn="ctr"/>
+            <a:r>
+              <a:rPr lang="en-US" sz="3000" dirty="0">
+                <a:latin typeface="Pixel Operator 8" panose="02000503000000000000" pitchFamily="2" charset="0"/>
+              </a:rPr>
+              <a:t>Survive for as many patterns as you can! </a:t>
+            </a:r>
+          </a:p>
+          <a:p>
+            <a:pPr algn="ctr"/>
+            <a:r>
+              <a:rPr lang="en-US" sz="3000" dirty="0">
+                <a:latin typeface="Pixel Operator 8" panose="02000503000000000000" pitchFamily="2" charset="0"/>
+              </a:rPr>
+              <a:t>Press Escape to return to the menu.</a:t>
+            </a:r>
+            <a:endParaRPr lang="fr-CA" sz="3000" dirty="0">
+              <a:latin typeface="Pixel Operator 8" panose="02000503000000000000" pitchFamily="2" charset="0"/>
+            </a:endParaRPr>
+          </a:p>
+        </p:txBody>
+      </p:sp>
+      <p:sp>
+        <p:nvSpPr>
+          <p:cNvPr id="13" name="Rectangle 12">
+            <a:extLst>
+              <a:ext uri="{FF2B5EF4-FFF2-40B4-BE49-F238E27FC236}">
+                <a16:creationId xmlns:a16="http://schemas.microsoft.com/office/drawing/2014/main" id="{B6E0CAA0-BFCF-A315-7CCF-7CE53C2419E2}"/>
+              </a:ext>
+            </a:extLst>
+          </p:cNvPr>
+          <p:cNvSpPr/>
+          <p:nvPr>
+            <p:custDataLst>
+              <p:tags r:id="rId3"/>
+            </p:custDataLst>
+          </p:nvPr>
+        </p:nvSpPr>
+        <p:spPr>
+          <a:xfrm>
+            <a:off x="979847" y="3641858"/>
+            <a:ext cx="10707329" cy="942792"/>
+          </a:xfrm>
+          <a:prstGeom prst="rect">
+            <a:avLst/>
+          </a:prstGeom>
+          <a:noFill/>
+          <a:ln>
+            <a:noFill/>
+          </a:ln>
+        </p:spPr>
+        <p:style>
+          <a:lnRef idx="2">
+            <a:schemeClr val="accent1">
+              <a:shade val="15000"/>
+            </a:schemeClr>
+          </a:lnRef>
+          <a:fillRef idx="1">
+            <a:schemeClr val="accent1"/>
+          </a:fillRef>
+          <a:effectRef idx="0">
+            <a:schemeClr val="accent1"/>
+          </a:effectRef>
+          <a:fontRef idx="minor">
+            <a:schemeClr val="lt1"/>
+          </a:fontRef>
+        </p:style>
+        <p:txBody>
+          <a:bodyPr rtlCol="0" anchor="ctr"/>
+          <a:lstStyle/>
+          <a:p>
+            <a:pPr algn="ctr"/>
+            <a:endParaRPr lang="fr-CA" sz="3000" dirty="0">
+              <a:latin typeface="Pixel Operator 8" panose="02000503000000000000" pitchFamily="2" charset="0"/>
+            </a:endParaRPr>
+          </a:p>
+        </p:txBody>
+      </p:sp>
+      <p:sp>
+        <p:nvSpPr>
+          <p:cNvPr id="14" name="Rectangle 13">
+            <a:extLst>
+              <a:ext uri="{FF2B5EF4-FFF2-40B4-BE49-F238E27FC236}">
+                <a16:creationId xmlns:a16="http://schemas.microsoft.com/office/drawing/2014/main" id="{A33A9CD3-F59A-B068-23A1-D241880A3EE3}"/>
+              </a:ext>
+            </a:extLst>
+          </p:cNvPr>
+          <p:cNvSpPr/>
+          <p:nvPr>
+            <p:custDataLst>
+              <p:tags r:id="rId4"/>
+            </p:custDataLst>
+          </p:nvPr>
+        </p:nvSpPr>
+        <p:spPr>
+          <a:xfrm>
+            <a:off x="1160204" y="5163146"/>
+            <a:ext cx="10707329" cy="942792"/>
+          </a:xfrm>
+          <a:prstGeom prst="rect">
+            <a:avLst/>
+          </a:prstGeom>
+          <a:noFill/>
+          <a:ln>
+            <a:noFill/>
+          </a:ln>
+        </p:spPr>
+        <p:style>
+          <a:lnRef idx="2">
+            <a:schemeClr val="accent1">
+              <a:shade val="15000"/>
+            </a:schemeClr>
+          </a:lnRef>
+          <a:fillRef idx="1">
+            <a:schemeClr val="accent1"/>
+          </a:fillRef>
+          <a:effectRef idx="0">
+            <a:schemeClr val="accent1"/>
+          </a:effectRef>
+          <a:fontRef idx="minor">
+            <a:schemeClr val="lt1"/>
+          </a:fontRef>
+        </p:style>
+        <p:txBody>
+          <a:bodyPr rtlCol="0" anchor="ctr"/>
+          <a:lstStyle/>
+          <a:p>
+            <a:pPr algn="ctr"/>
+            <a:endParaRPr lang="fr-CA" sz="3000" dirty="0">
+              <a:latin typeface="Pixel Operator 8" panose="02000503000000000000" pitchFamily="2" charset="0"/>
+            </a:endParaRPr>
+          </a:p>
+        </p:txBody>
+      </p:sp>
+      <p:sp>
+        <p:nvSpPr>
+          <p:cNvPr id="18" name="Rectangle 17">
+            <a:extLst>
+              <a:ext uri="{FF2B5EF4-FFF2-40B4-BE49-F238E27FC236}">
+                <a16:creationId xmlns:a16="http://schemas.microsoft.com/office/drawing/2014/main" id="{40C9BEB0-C130-779C-0340-09EE2D4C0D40}"/>
+              </a:ext>
+            </a:extLst>
+          </p:cNvPr>
+          <p:cNvSpPr/>
+          <p:nvPr>
+            <p:custDataLst>
+              <p:tags r:id="rId5"/>
+            </p:custDataLst>
+          </p:nvPr>
+        </p:nvSpPr>
+        <p:spPr>
+          <a:xfrm>
+            <a:off x="245806" y="403123"/>
+            <a:ext cx="11759381" cy="6194321"/>
+          </a:xfrm>
+          <a:prstGeom prst="rect">
+            <a:avLst/>
+          </a:prstGeom>
+          <a:noFill/>
+          <a:ln>
+            <a:solidFill>
+              <a:schemeClr val="bg1"/>
+            </a:solidFill>
+          </a:ln>
+        </p:spPr>
+        <p:style>
+          <a:lnRef idx="2">
+            <a:schemeClr val="accent1">
+              <a:shade val="15000"/>
+            </a:schemeClr>
+          </a:lnRef>
+          <a:fillRef idx="1">
+            <a:schemeClr val="accent1"/>
+          </a:fillRef>
+          <a:effectRef idx="0">
+            <a:schemeClr val="accent1"/>
+          </a:effectRef>
+          <a:fontRef idx="minor">
+            <a:schemeClr val="lt1"/>
+          </a:fontRef>
+        </p:style>
+        <p:txBody>
+          <a:bodyPr rtlCol="0" anchor="ctr"/>
+          <a:lstStyle/>
+          <a:p>
+            <a:pPr algn="ctr"/>
+            <a:endParaRPr lang="fr-CA"/>
+          </a:p>
+        </p:txBody>
+      </p:sp>
+      <p:pic>
+        <p:nvPicPr>
+          <p:cNvPr id="7" name="Image 6">
+            <a:extLst>
+              <a:ext uri="{FF2B5EF4-FFF2-40B4-BE49-F238E27FC236}">
+                <a16:creationId xmlns:a16="http://schemas.microsoft.com/office/drawing/2014/main" id="{81FA5964-DE4F-03F3-227D-9B46145B08EA}"/>
+              </a:ext>
+            </a:extLst>
+          </p:cNvPr>
+          <p:cNvPicPr>
+            <a:picLocks noChangeAspect="1"/>
+          </p:cNvPicPr>
+          <p:nvPr>
+            <p:custDataLst>
+              <p:tags r:id="rId6"/>
+            </p:custDataLst>
+          </p:nvPr>
+        </p:nvPicPr>
+        <p:blipFill>
+          <a:blip r:embed="rId9"/>
+          <a:srcRect l="4895" r="4092"/>
+          <a:stretch>
+            <a:fillRect/>
+          </a:stretch>
+        </p:blipFill>
+        <p:spPr>
+          <a:xfrm>
+            <a:off x="3864077" y="0"/>
+            <a:ext cx="4463845" cy="1053879"/>
+          </a:xfrm>
+          <a:prstGeom prst="rect">
+            <a:avLst/>
+          </a:prstGeom>
+        </p:spPr>
+      </p:pic>
+      <p:pic>
+        <p:nvPicPr>
+          <p:cNvPr id="6" name="Image 5">
+            <a:extLst>
+              <a:ext uri="{FF2B5EF4-FFF2-40B4-BE49-F238E27FC236}">
+                <a16:creationId xmlns:a16="http://schemas.microsoft.com/office/drawing/2014/main" id="{93F6D3C7-FD49-FCDE-7032-C1770CC74CC6}"/>
+              </a:ext>
+            </a:extLst>
+          </p:cNvPr>
+          <p:cNvPicPr>
+            <a:picLocks noChangeAspect="1"/>
+          </p:cNvPicPr>
+          <p:nvPr/>
+        </p:nvPicPr>
+        <p:blipFill>
+          <a:blip r:embed="rId10">
+            <a:duotone>
+              <a:schemeClr val="bg2">
+                <a:shade val="45000"/>
+                <a:satMod val="135000"/>
+              </a:schemeClr>
+              <a:prstClr val="white"/>
+            </a:duotone>
+            <a:extLst>
+              <a:ext uri="{BEBA8EAE-BF5A-486C-A8C5-ECC9F3942E4B}">
+                <a14:imgProps xmlns:a14="http://schemas.microsoft.com/office/drawing/2010/main">
+                  <a14:imgLayer r:embed="rId11">
+                    <a14:imgEffect>
+                      <a14:colorTemperature colorTemp="4700"/>
+                    </a14:imgEffect>
+                    <a14:imgEffect>
+                      <a14:saturation sat="0"/>
+                    </a14:imgEffect>
+                  </a14:imgLayer>
+                </a14:imgProps>
+              </a:ext>
+            </a:extLst>
+          </a:blip>
+          <a:srcRect l="1287" t="17358" r="73201" b="14299"/>
+          <a:stretch>
+            <a:fillRect/>
+          </a:stretch>
+        </p:blipFill>
+        <p:spPr>
+          <a:xfrm rot="10800000">
+            <a:off x="11433373" y="6098266"/>
+            <a:ext cx="758627" cy="759734"/>
+          </a:xfrm>
+          <a:prstGeom prst="rect">
+            <a:avLst/>
+          </a:prstGeom>
+        </p:spPr>
+      </p:pic>
+      <p:pic>
+        <p:nvPicPr>
+          <p:cNvPr id="3" name="Image 2">
+            <a:extLst>
+              <a:ext uri="{FF2B5EF4-FFF2-40B4-BE49-F238E27FC236}">
+                <a16:creationId xmlns:a16="http://schemas.microsoft.com/office/drawing/2014/main" id="{EC1D5DF9-2F4B-7C8D-846A-7C5EEFB8CF24}"/>
+              </a:ext>
+            </a:extLst>
+          </p:cNvPr>
+          <p:cNvPicPr>
+            <a:picLocks noChangeAspect="1"/>
+          </p:cNvPicPr>
+          <p:nvPr/>
+        </p:nvPicPr>
+        <p:blipFill>
+          <a:blip r:embed="rId10">
+            <a:duotone>
+              <a:schemeClr val="bg2">
+                <a:shade val="45000"/>
+                <a:satMod val="135000"/>
+              </a:schemeClr>
+              <a:prstClr val="white"/>
+            </a:duotone>
+            <a:extLst>
+              <a:ext uri="{BEBA8EAE-BF5A-486C-A8C5-ECC9F3942E4B}">
+                <a14:imgProps xmlns:a14="http://schemas.microsoft.com/office/drawing/2010/main">
+                  <a14:imgLayer r:embed="rId11">
+                    <a14:imgEffect>
+                      <a14:colorTemperature colorTemp="4700"/>
+                    </a14:imgEffect>
+                    <a14:imgEffect>
+                      <a14:saturation sat="0"/>
+                    </a14:imgEffect>
+                  </a14:imgLayer>
+                </a14:imgProps>
+              </a:ext>
+            </a:extLst>
+          </a:blip>
+          <a:srcRect l="1287" t="17358" r="73201" b="14299"/>
+          <a:stretch>
+            <a:fillRect/>
+          </a:stretch>
+        </p:blipFill>
+        <p:spPr>
+          <a:xfrm>
+            <a:off x="0" y="6098266"/>
+            <a:ext cx="758627" cy="759734"/>
+          </a:xfrm>
+          <a:prstGeom prst="rect">
+            <a:avLst/>
+          </a:prstGeom>
+        </p:spPr>
+      </p:pic>
+      <p:pic>
+        <p:nvPicPr>
+          <p:cNvPr id="9" name="Image 8">
+            <a:extLst>
+              <a:ext uri="{FF2B5EF4-FFF2-40B4-BE49-F238E27FC236}">
+                <a16:creationId xmlns:a16="http://schemas.microsoft.com/office/drawing/2014/main" id="{785A035C-9FCB-00FE-3119-051BD8FBA74C}"/>
+              </a:ext>
+            </a:extLst>
+          </p:cNvPr>
+          <p:cNvPicPr>
+            <a:picLocks noChangeAspect="1"/>
+          </p:cNvPicPr>
+          <p:nvPr/>
+        </p:nvPicPr>
+        <p:blipFill>
+          <a:blip r:embed="rId12"/>
+          <a:stretch>
+            <a:fillRect/>
+          </a:stretch>
+        </p:blipFill>
+        <p:spPr>
+          <a:xfrm>
+            <a:off x="8475620" y="448750"/>
+            <a:ext cx="2309311" cy="2309311"/>
+          </a:xfrm>
+          <a:prstGeom prst="rect">
+            <a:avLst/>
+          </a:prstGeom>
+        </p:spPr>
+      </p:pic>
+      <p:pic>
+        <p:nvPicPr>
+          <p:cNvPr id="15" name="Image 14">
+            <a:extLst>
+              <a:ext uri="{FF2B5EF4-FFF2-40B4-BE49-F238E27FC236}">
+                <a16:creationId xmlns:a16="http://schemas.microsoft.com/office/drawing/2014/main" id="{431D45F4-97E9-8B3F-98F7-6C5430807104}"/>
+              </a:ext>
+            </a:extLst>
+          </p:cNvPr>
+          <p:cNvPicPr>
+            <a:picLocks noChangeAspect="1"/>
+          </p:cNvPicPr>
+          <p:nvPr>
+            <p:custDataLst>
+              <p:tags r:id="rId7"/>
+            </p:custDataLst>
+          </p:nvPr>
+        </p:nvPicPr>
+        <p:blipFill>
+          <a:blip r:embed="rId13"/>
+          <a:stretch>
+            <a:fillRect/>
+          </a:stretch>
+        </p:blipFill>
+        <p:spPr>
+          <a:xfrm>
+            <a:off x="1013210" y="4726821"/>
+            <a:ext cx="1145098" cy="1187505"/>
+          </a:xfrm>
+          <a:prstGeom prst="rect">
+            <a:avLst/>
+          </a:prstGeom>
+        </p:spPr>
+      </p:pic>
+    </p:spTree>
+    <p:extLst>
+      <p:ext uri="{BB962C8B-B14F-4D97-AF65-F5344CB8AC3E}">
+        <p14:creationId xmlns:p14="http://schemas.microsoft.com/office/powerpoint/2010/main" val="179919952"/>
+      </p:ext>
+    </p:extLst>
+  </p:cSld>
+  <p:clrMapOvr>
+    <a:masterClrMapping/>
+  </p:clrMapOvr>
+</p:sld>
+</file>
+
+<file path=ppt/slides/slide3.xml><?xml version="1.0" encoding="utf-8"?>
+<p:sld xmlns:a="http://schemas.openxmlformats.org/drawingml/2006/main" xmlns:r="http://schemas.openxmlformats.org/officeDocument/2006/relationships" xmlns:p="http://schemas.openxmlformats.org/presentationml/2006/main">
+  <p:cSld>
+    <p:spTree>
+      <p:nvGrpSpPr>
+        <p:cNvPr id="1" name="">
+          <a:extLst>
+            <a:ext uri="{FF2B5EF4-FFF2-40B4-BE49-F238E27FC236}">
               <a16:creationId xmlns:a16="http://schemas.microsoft.com/office/drawing/2014/main" id="{92BB697C-39AB-850F-C6FD-9D089FF2EAC4}"/>
             </a:ext>
           </a:extLst>
@@ -4601,7 +5126,7 @@
 </p:sld>
 </file>
 
-<file path=ppt/slides/slide3.xml><?xml version="1.0" encoding="utf-8"?>
+<file path=ppt/slides/slide4.xml><?xml version="1.0" encoding="utf-8"?>
 <p:sld xmlns:a="http://schemas.openxmlformats.org/drawingml/2006/main" xmlns:r="http://schemas.openxmlformats.org/officeDocument/2006/relationships" xmlns:p="http://schemas.openxmlformats.org/presentationml/2006/main">
   <p:cSld>
     <p:spTree>
@@ -5104,7 +5629,7 @@
 </p:sld>
 </file>
 
-<file path=ppt/slides/slide4.xml><?xml version="1.0" encoding="utf-8"?>
+<file path=ppt/slides/slide5.xml><?xml version="1.0" encoding="utf-8"?>
 <p:sld xmlns:a="http://schemas.openxmlformats.org/drawingml/2006/main" xmlns:r="http://schemas.openxmlformats.org/officeDocument/2006/relationships" xmlns:p="http://schemas.openxmlformats.org/presentationml/2006/main">
   <p:cSld>
     <p:spTree>
@@ -5490,7 +6015,7 @@
 </p:sld>
 </file>
 
-<file path=ppt/slides/slide5.xml><?xml version="1.0" encoding="utf-8"?>
+<file path=ppt/slides/slide6.xml><?xml version="1.0" encoding="utf-8"?>
 <p:sld xmlns:a="http://schemas.openxmlformats.org/drawingml/2006/main" xmlns:r="http://schemas.openxmlformats.org/officeDocument/2006/relationships" xmlns:p="http://schemas.openxmlformats.org/presentationml/2006/main">
   <p:cSld>
     <p:spTree>
@@ -5849,31 +6374,31 @@
 
 <file path=ppt/tags/tag13.xml><?xml version="1.0" encoding="utf-8"?>
 <p:tagLst xmlns:a="http://schemas.openxmlformats.org/drawingml/2006/main" xmlns:r="http://schemas.openxmlformats.org/officeDocument/2006/relationships" xmlns:p="http://schemas.openxmlformats.org/presentationml/2006/main">
-  <p:tag name="NUM" val="2"/>
+  <p:tag name="NUM" val="4"/>
 </p:tagLst>
 </file>
 
 <file path=ppt/tags/tag14.xml><?xml version="1.0" encoding="utf-8"?>
 <p:tagLst xmlns:a="http://schemas.openxmlformats.org/drawingml/2006/main" xmlns:r="http://schemas.openxmlformats.org/officeDocument/2006/relationships" xmlns:p="http://schemas.openxmlformats.org/presentationml/2006/main">
-  <p:tag name="NUM" val="3"/>
+  <p:tag name="NUM" val="7"/>
 </p:tagLst>
 </file>
 
 <file path=ppt/tags/tag15.xml><?xml version="1.0" encoding="utf-8"?>
 <p:tagLst xmlns:a="http://schemas.openxmlformats.org/drawingml/2006/main" xmlns:r="http://schemas.openxmlformats.org/officeDocument/2006/relationships" xmlns:p="http://schemas.openxmlformats.org/presentationml/2006/main">
-  <p:tag name="NUM" val="4"/>
+  <p:tag name="NUM" val="8"/>
 </p:tagLst>
 </file>
 
 <file path=ppt/tags/tag16.xml><?xml version="1.0" encoding="utf-8"?>
 <p:tagLst xmlns:a="http://schemas.openxmlformats.org/drawingml/2006/main" xmlns:r="http://schemas.openxmlformats.org/officeDocument/2006/relationships" xmlns:p="http://schemas.openxmlformats.org/presentationml/2006/main">
-  <p:tag name="NUM" val="5"/>
+  <p:tag name="NUM" val="10"/>
 </p:tagLst>
 </file>
 
 <file path=ppt/tags/tag17.xml><?xml version="1.0" encoding="utf-8"?>
 <p:tagLst xmlns:a="http://schemas.openxmlformats.org/drawingml/2006/main" xmlns:r="http://schemas.openxmlformats.org/officeDocument/2006/relationships" xmlns:p="http://schemas.openxmlformats.org/presentationml/2006/main">
-  <p:tag name="NUM" val="1"/>
+  <p:tag name="NUM" val="11"/>
 </p:tagLst>
 </file>
 
@@ -5885,7 +6410,7 @@
 
 <file path=ppt/tags/tag19.xml><?xml version="1.0" encoding="utf-8"?>
 <p:tagLst xmlns:a="http://schemas.openxmlformats.org/drawingml/2006/main" xmlns:r="http://schemas.openxmlformats.org/officeDocument/2006/relationships" xmlns:p="http://schemas.openxmlformats.org/presentationml/2006/main">
-  <p:tag name="NUM" val="3"/>
+  <p:tag name="NUM" val="1"/>
 </p:tagLst>
 </file>
 
@@ -5897,61 +6422,61 @@
 
 <file path=ppt/tags/tag20.xml><?xml version="1.0" encoding="utf-8"?>
 <p:tagLst xmlns:a="http://schemas.openxmlformats.org/drawingml/2006/main" xmlns:r="http://schemas.openxmlformats.org/officeDocument/2006/relationships" xmlns:p="http://schemas.openxmlformats.org/presentationml/2006/main">
-  <p:tag name="NUM" val="4"/>
+  <p:tag name="NUM" val="2"/>
 </p:tagLst>
 </file>
 
 <file path=ppt/tags/tag21.xml><?xml version="1.0" encoding="utf-8"?>
 <p:tagLst xmlns:a="http://schemas.openxmlformats.org/drawingml/2006/main" xmlns:r="http://schemas.openxmlformats.org/officeDocument/2006/relationships" xmlns:p="http://schemas.openxmlformats.org/presentationml/2006/main">
-  <p:tag name="NUM" val="5"/>
+  <p:tag name="NUM" val="3"/>
 </p:tagLst>
 </file>
 
 <file path=ppt/tags/tag22.xml><?xml version="1.0" encoding="utf-8"?>
 <p:tagLst xmlns:a="http://schemas.openxmlformats.org/drawingml/2006/main" xmlns:r="http://schemas.openxmlformats.org/officeDocument/2006/relationships" xmlns:p="http://schemas.openxmlformats.org/presentationml/2006/main">
-  <p:tag name="NUM" val="1"/>
+  <p:tag name="NUM" val="4"/>
 </p:tagLst>
 </file>
 
 <file path=ppt/tags/tag23.xml><?xml version="1.0" encoding="utf-8"?>
 <p:tagLst xmlns:a="http://schemas.openxmlformats.org/drawingml/2006/main" xmlns:r="http://schemas.openxmlformats.org/officeDocument/2006/relationships" xmlns:p="http://schemas.openxmlformats.org/presentationml/2006/main">
-  <p:tag name="NUM" val="2"/>
+  <p:tag name="NUM" val="5"/>
 </p:tagLst>
 </file>
 
 <file path=ppt/tags/tag24.xml><?xml version="1.0" encoding="utf-8"?>
 <p:tagLst xmlns:a="http://schemas.openxmlformats.org/drawingml/2006/main" xmlns:r="http://schemas.openxmlformats.org/officeDocument/2006/relationships" xmlns:p="http://schemas.openxmlformats.org/presentationml/2006/main">
-  <p:tag name="NUM" val="3"/>
+  <p:tag name="NUM" val="1"/>
 </p:tagLst>
 </file>
 
 <file path=ppt/tags/tag25.xml><?xml version="1.0" encoding="utf-8"?>
 <p:tagLst xmlns:a="http://schemas.openxmlformats.org/drawingml/2006/main" xmlns:r="http://schemas.openxmlformats.org/officeDocument/2006/relationships" xmlns:p="http://schemas.openxmlformats.org/presentationml/2006/main">
-  <p:tag name="NUM" val="4"/>
+  <p:tag name="NUM" val="2"/>
 </p:tagLst>
 </file>
 
 <file path=ppt/tags/tag26.xml><?xml version="1.0" encoding="utf-8"?>
 <p:tagLst xmlns:a="http://schemas.openxmlformats.org/drawingml/2006/main" xmlns:r="http://schemas.openxmlformats.org/officeDocument/2006/relationships" xmlns:p="http://schemas.openxmlformats.org/presentationml/2006/main">
-  <p:tag name="NUM" val="5"/>
+  <p:tag name="NUM" val="3"/>
 </p:tagLst>
 </file>
 
 <file path=ppt/tags/tag27.xml><?xml version="1.0" encoding="utf-8"?>
 <p:tagLst xmlns:a="http://schemas.openxmlformats.org/drawingml/2006/main" xmlns:r="http://schemas.openxmlformats.org/officeDocument/2006/relationships" xmlns:p="http://schemas.openxmlformats.org/presentationml/2006/main">
-  <p:tag name="NUM" val="1"/>
+  <p:tag name="NUM" val="4"/>
 </p:tagLst>
 </file>
 
 <file path=ppt/tags/tag28.xml><?xml version="1.0" encoding="utf-8"?>
 <p:tagLst xmlns:a="http://schemas.openxmlformats.org/drawingml/2006/main" xmlns:r="http://schemas.openxmlformats.org/officeDocument/2006/relationships" xmlns:p="http://schemas.openxmlformats.org/presentationml/2006/main">
-  <p:tag name="NUM" val="2"/>
+  <p:tag name="NUM" val="5"/>
 </p:tagLst>
 </file>
 
 <file path=ppt/tags/tag29.xml><?xml version="1.0" encoding="utf-8"?>
 <p:tagLst xmlns:a="http://schemas.openxmlformats.org/drawingml/2006/main" xmlns:r="http://schemas.openxmlformats.org/officeDocument/2006/relationships" xmlns:p="http://schemas.openxmlformats.org/presentationml/2006/main">
-  <p:tag name="NUM" val="3"/>
+  <p:tag name="NUM" val="1"/>
 </p:tagLst>
 </file>
 
@@ -5963,11 +6488,53 @@
 
 <file path=ppt/tags/tag30.xml><?xml version="1.0" encoding="utf-8"?>
 <p:tagLst xmlns:a="http://schemas.openxmlformats.org/drawingml/2006/main" xmlns:r="http://schemas.openxmlformats.org/officeDocument/2006/relationships" xmlns:p="http://schemas.openxmlformats.org/presentationml/2006/main">
+  <p:tag name="NUM" val="2"/>
+</p:tagLst>
+</file>
+
+<file path=ppt/tags/tag31.xml><?xml version="1.0" encoding="utf-8"?>
+<p:tagLst xmlns:a="http://schemas.openxmlformats.org/drawingml/2006/main" xmlns:r="http://schemas.openxmlformats.org/officeDocument/2006/relationships" xmlns:p="http://schemas.openxmlformats.org/presentationml/2006/main">
+  <p:tag name="NUM" val="3"/>
+</p:tagLst>
+</file>
+
+<file path=ppt/tags/tag32.xml><?xml version="1.0" encoding="utf-8"?>
+<p:tagLst xmlns:a="http://schemas.openxmlformats.org/drawingml/2006/main" xmlns:r="http://schemas.openxmlformats.org/officeDocument/2006/relationships" xmlns:p="http://schemas.openxmlformats.org/presentationml/2006/main">
   <p:tag name="NUM" val="4"/>
 </p:tagLst>
 </file>
 
-<file path=ppt/tags/tag31.xml><?xml version="1.0" encoding="utf-8"?>
+<file path=ppt/tags/tag33.xml><?xml version="1.0" encoding="utf-8"?>
+<p:tagLst xmlns:a="http://schemas.openxmlformats.org/drawingml/2006/main" xmlns:r="http://schemas.openxmlformats.org/officeDocument/2006/relationships" xmlns:p="http://schemas.openxmlformats.org/presentationml/2006/main">
+  <p:tag name="NUM" val="5"/>
+</p:tagLst>
+</file>
+
+<file path=ppt/tags/tag34.xml><?xml version="1.0" encoding="utf-8"?>
+<p:tagLst xmlns:a="http://schemas.openxmlformats.org/drawingml/2006/main" xmlns:r="http://schemas.openxmlformats.org/officeDocument/2006/relationships" xmlns:p="http://schemas.openxmlformats.org/presentationml/2006/main">
+  <p:tag name="NUM" val="1"/>
+</p:tagLst>
+</file>
+
+<file path=ppt/tags/tag35.xml><?xml version="1.0" encoding="utf-8"?>
+<p:tagLst xmlns:a="http://schemas.openxmlformats.org/drawingml/2006/main" xmlns:r="http://schemas.openxmlformats.org/officeDocument/2006/relationships" xmlns:p="http://schemas.openxmlformats.org/presentationml/2006/main">
+  <p:tag name="NUM" val="2"/>
+</p:tagLst>
+</file>
+
+<file path=ppt/tags/tag36.xml><?xml version="1.0" encoding="utf-8"?>
+<p:tagLst xmlns:a="http://schemas.openxmlformats.org/drawingml/2006/main" xmlns:r="http://schemas.openxmlformats.org/officeDocument/2006/relationships" xmlns:p="http://schemas.openxmlformats.org/presentationml/2006/main">
+  <p:tag name="NUM" val="3"/>
+</p:tagLst>
+</file>
+
+<file path=ppt/tags/tag37.xml><?xml version="1.0" encoding="utf-8"?>
+<p:tagLst xmlns:a="http://schemas.openxmlformats.org/drawingml/2006/main" xmlns:r="http://schemas.openxmlformats.org/officeDocument/2006/relationships" xmlns:p="http://schemas.openxmlformats.org/presentationml/2006/main">
+  <p:tag name="NUM" val="4"/>
+</p:tagLst>
+</file>
+
+<file path=ppt/tags/tag38.xml><?xml version="1.0" encoding="utf-8"?>
 <p:tagLst xmlns:a="http://schemas.openxmlformats.org/drawingml/2006/main" xmlns:r="http://schemas.openxmlformats.org/officeDocument/2006/relationships" xmlns:p="http://schemas.openxmlformats.org/presentationml/2006/main">
   <p:tag name="NUM" val="5"/>
 </p:tagLst>

</xml_diff>